<commit_message>
Deck, README and evaluation prep: reference period, weight basis, the two heat-map questions
Co-Authored-By: Claude Opus 5 <noreply@anthropic.com>
Claude-Session: https://claude.ai/code/session_0129UjVhHMAVJgfcaxoN1dD5
</commit_message>
<xml_diff>
--- a/SIH26056-Idea-Presentation.pptx
+++ b/SIH26056-Idea-Presentation.pptx
@@ -7463,7 +7463,7 @@
                 </a:solidFill>
                 <a:latin typeface="Arial"/>
               </a:rPr>
-              <a:t>route seat share × lead-time share</a:t>
+              <a:t>seat share (passenger proxy) × lead time</a:t>
             </a:r>
           </a:p>
         </p:txBody>
@@ -7553,7 +7553,7 @@
                 </a:solidFill>
                 <a:latin typeface="Arial"/>
               </a:rPr>
-              <a:t>first observation day = 100</a:t>
+              <a:t>first 3 full-coverage days, averaged = 100</a:t>
             </a:r>
           </a:p>
         </p:txBody>

</xml_diff>

<commit_message>
Deck and eval prep: the block, the monitor and the licensed feed, as they happened
Co-Authored-By: Claude Opus 5 <noreply@anthropic.com>
Claude-Session: https://claude.ai/code/session_0129UjVhHMAVJgfcaxoN1dD5
</commit_message>
<xml_diff>
--- a/SIH26056-Idea-Presentation.pptx
+++ b/SIH26056-Idea-Presentation.pptx
@@ -6200,7 +6200,7 @@
                 </a:solidFill>
                 <a:latin typeface="Arial"/>
               </a:rPr>
-              <a:t>158,000+ fares collected · 15 city pairs × 5 lead times · every 10 minutes · ₹0 a month to run</a:t>
+              <a:t>209,000+ fares · 15 city pairs × 5 lead times · every 10 minutes · scraped, then a licensed feed · ₹0 a month</a:t>
             </a:r>
           </a:p>
         </p:txBody>
@@ -10850,7 +10850,7 @@
                 </a:solidFill>
                 <a:latin typeface="Arial"/>
               </a:rPr>
-              <a:t>STACK   Python · Playwright · LLM extraction with failover · Pydantic v2 · Supabase PostgreSQL · FastAPI · Cloudflare · cron</a:t>
+              <a:t>STACK   Python · Playwright · LLM extraction with failover · Pydantic v2 · Supabase · FastAPI · Cloudflare · cron · source monitor · licensed feed</a:t>
             </a:r>
           </a:p>
         </p:txBody>
@@ -12337,7 +12337,7 @@
                 </a:solidFill>
                 <a:latin typeface="Arial"/>
               </a:rPr>
-              <a:t>16 portals surveyed, one is usable</a:t>
+              <a:t>One portal was usable — then it closed</a:t>
             </a:r>
           </a:p>
           <a:p>
@@ -12359,7 +12359,7 @@
                 </a:solidFill>
                 <a:latin typeface="Arial"/>
               </a:rPr>
-              <a:t>Ten disallow us, four block us, airlines refuse automation entirely.</a:t>
+              <a:t>Cleartrip put its search API behind Akamai on 15 Sep. We did not evade it.</a:t>
             </a:r>
           </a:p>
         </p:txBody>
@@ -12494,7 +12494,7 @@
                 </a:solidFill>
                 <a:latin typeface="Arial"/>
               </a:rPr>
-              <a:t>Cloud IPs are blocked too</a:t>
+              <a:t>A source can vanish overnight</a:t>
             </a:r>
           </a:p>
           <a:p>
@@ -12516,7 +12516,7 @@
                 </a:solidFill>
                 <a:latin typeface="Arial"/>
               </a:rPr>
-              <a:t>Verified in CI — so collection runs from a residential host.</a:t>
+              <a:t>A monitor scores every run and names the failure: a layout change is repaired, a block is never evaded.</a:t>
             </a:r>
           </a:p>
         </p:txBody>
@@ -12651,7 +12651,7 @@
                 </a:solidFill>
                 <a:latin typeface="Arial"/>
               </a:rPr>
-              <a:t>Models get retired without notice</a:t>
+              <a:t>So the data now comes from a licensed feed</a:t>
             </a:r>
           </a:p>
           <a:p>
@@ -12673,7 +12673,7 @@
                 </a:solidFill>
                 <a:latin typeface="Arial"/>
               </a:rPr>
-              <a:t>Three died during this build. Extraction now fails over automatically.</a:t>
+              <a:t>Aviasales Data API, one-way fares, every 10 minutes — its own segment, not spliced onto the old series.</a:t>
             </a:r>
           </a:p>
         </p:txBody>
@@ -12808,7 +12808,7 @@
                 </a:solidFill>
                 <a:latin typeface="Arial"/>
               </a:rPr>
-              <a:t>Thin coverage would mislead</a:t>
+              <a:t>Models get retired without notice</a:t>
             </a:r>
           </a:p>
           <a:p>
@@ -12830,7 +12830,7 @@
                 </a:solidFill>
                 <a:latin typeface="Arial"/>
               </a:rPr>
-              <a:t>Days below 60% basket weight publish as provisional, with the reason.</a:t>
+              <a:t>Three died during this build. Extraction now fails over automatically.</a:t>
             </a:r>
           </a:p>
         </p:txBody>

</xml_diff>